<commit_message>
Content-Fixes aus Validator-Lauf: M22 Trainer-Hinweis-Leak entfernt, M08 Stufen-Wording; Artefakte regeneriert
Co-Authored-By: Claude Fable 5 <noreply@anthropic.com>
</commit_message>
<xml_diff>
--- a/protected-downloads/praesentation/M05.pptx
+++ b/protected-downloads/praesentation/M05.pptx
@@ -4025,7 +4025,42 @@
       </p:sp>
       <p:sp>
         <p:nvSpPr>
-          <p:cNvPr id="6" name="Rectangle 5"/>
+          <p:cNvPr id="6" name="TextBox 5"/>
+          <p:cNvSpPr txBox="1"/>
+          <p:nvPr/>
+        </p:nvSpPr>
+        <p:spPr>
+          <a:xfrm>
+            <a:off x="685800" y="3977639"/>
+            <a:ext cx="10817352" cy="731520"/>
+          </a:xfrm>
+          <a:prstGeom prst="rect">
+            <a:avLst/>
+          </a:prstGeom>
+          <a:noFill/>
+        </p:spPr>
+        <p:txBody>
+          <a:bodyPr wrap="square">
+            <a:spAutoFit/>
+          </a:bodyPr>
+          <a:lstStyle/>
+          <a:p>
+            <a:pPr algn="l"/>
+            <a:r>
+              <a:rPr sz="1900" b="0" i="1">
+                <a:solidFill>
+                  <a:srgbClr val="BECDE6"/>
+                </a:solidFill>
+                <a:latin typeface="Source Serif 4"/>
+              </a:rPr>
+              <a:t>Systematische Branchenrisikoanalyse als Basis für differenzierte Kreditentscheidungen</a:t>
+            </a:r>
+          </a:p>
+        </p:txBody>
+      </p:sp>
+      <p:sp>
+        <p:nvSpPr>
+          <p:cNvPr id="7" name="Rectangle 6"/>
           <p:cNvSpPr/>
           <p:nvPr/>
         </p:nvSpPr>
@@ -4068,14 +4103,14 @@
       </p:sp>
       <p:sp>
         <p:nvSpPr>
-          <p:cNvPr id="7" name="TextBox 6"/>
+          <p:cNvPr id="8" name="TextBox 7"/>
           <p:cNvSpPr txBox="1"/>
           <p:nvPr/>
         </p:nvSpPr>
         <p:spPr>
           <a:xfrm>
             <a:off x="685800" y="5193792"/>
-            <a:ext cx="10817352" cy="201168"/>
+            <a:ext cx="3605784" cy="201168"/>
           </a:xfrm>
           <a:prstGeom prst="rect">
             <a:avLst/>
@@ -4096,21 +4131,21 @@
                 </a:solidFill>
                 <a:latin typeface="JetBrains Mono"/>
               </a:rPr>
-              <a:t>VERSION</a:t>
-            </a:r>
-          </a:p>
-        </p:txBody>
-      </p:sp>
-      <p:sp>
-        <p:nvSpPr>
-          <p:cNvPr id="8" name="TextBox 7"/>
+              <a:t>KOMPETENZFELD</a:t>
+            </a:r>
+          </a:p>
+        </p:txBody>
+      </p:sp>
+      <p:sp>
+        <p:nvSpPr>
+          <p:cNvPr id="9" name="TextBox 8"/>
           <p:cNvSpPr txBox="1"/>
           <p:nvPr/>
         </p:nvSpPr>
         <p:spPr>
           <a:xfrm>
             <a:off x="685800" y="5394960"/>
-            <a:ext cx="10817352" cy="320040"/>
+            <a:ext cx="3605784" cy="320040"/>
           </a:xfrm>
           <a:prstGeom prst="rect">
             <a:avLst/>
@@ -4131,14 +4166,154 @@
                 </a:solidFill>
                 <a:latin typeface="Arial"/>
               </a:rPr>
-              <a:t>v0.3_KERN</a:t>
-            </a:r>
-          </a:p>
-        </p:txBody>
-      </p:sp>
-      <p:sp>
-        <p:nvSpPr>
-          <p:cNvPr id="9" name="Rectangle 8"/>
+              <a:t>K-01 Finanzanalyse &amp; Kreditexpertise</a:t>
+            </a:r>
+          </a:p>
+        </p:txBody>
+      </p:sp>
+      <p:sp>
+        <p:nvSpPr>
+          <p:cNvPr id="10" name="TextBox 9"/>
+          <p:cNvSpPr txBox="1"/>
+          <p:nvPr/>
+        </p:nvSpPr>
+        <p:spPr>
+          <a:xfrm>
+            <a:off x="4291584" y="5193792"/>
+            <a:ext cx="3605784" cy="201168"/>
+          </a:xfrm>
+          <a:prstGeom prst="rect">
+            <a:avLst/>
+          </a:prstGeom>
+          <a:noFill/>
+        </p:spPr>
+        <p:txBody>
+          <a:bodyPr wrap="none">
+            <a:spAutoFit/>
+          </a:bodyPr>
+          <a:lstStyle/>
+          <a:p>
+            <a:pPr algn="l"/>
+            <a:r>
+              <a:rPr sz="700">
+                <a:solidFill>
+                  <a:srgbClr val="A0B4D2"/>
+                </a:solidFill>
+                <a:latin typeface="JetBrains Mono"/>
+              </a:rPr>
+              <a:t>KOMPETENZSTUFE</a:t>
+            </a:r>
+          </a:p>
+        </p:txBody>
+      </p:sp>
+      <p:sp>
+        <p:nvSpPr>
+          <p:cNvPr id="11" name="TextBox 10"/>
+          <p:cNvSpPr txBox="1"/>
+          <p:nvPr/>
+        </p:nvSpPr>
+        <p:spPr>
+          <a:xfrm>
+            <a:off x="4291584" y="5394960"/>
+            <a:ext cx="3605784" cy="320040"/>
+          </a:xfrm>
+          <a:prstGeom prst="rect">
+            <a:avLst/>
+          </a:prstGeom>
+          <a:noFill/>
+        </p:spPr>
+        <p:txBody>
+          <a:bodyPr wrap="square">
+            <a:spAutoFit/>
+          </a:bodyPr>
+          <a:lstStyle/>
+          <a:p>
+            <a:pPr algn="l"/>
+            <a:r>
+              <a:rPr sz="1100" b="0" i="0">
+                <a:solidFill>
+                  <a:srgbClr val="FFFFFF"/>
+                </a:solidFill>
+                <a:latin typeface="Arial"/>
+              </a:rPr>
+              <a:t>Strategischer Partner</a:t>
+            </a:r>
+          </a:p>
+        </p:txBody>
+      </p:sp>
+      <p:sp>
+        <p:nvSpPr>
+          <p:cNvPr id="12" name="TextBox 11"/>
+          <p:cNvSpPr txBox="1"/>
+          <p:nvPr/>
+        </p:nvSpPr>
+        <p:spPr>
+          <a:xfrm>
+            <a:off x="7897368" y="5193792"/>
+            <a:ext cx="3605784" cy="201168"/>
+          </a:xfrm>
+          <a:prstGeom prst="rect">
+            <a:avLst/>
+          </a:prstGeom>
+          <a:noFill/>
+        </p:spPr>
+        <p:txBody>
+          <a:bodyPr wrap="none">
+            <a:spAutoFit/>
+          </a:bodyPr>
+          <a:lstStyle/>
+          <a:p>
+            <a:pPr algn="l"/>
+            <a:r>
+              <a:rPr sz="700">
+                <a:solidFill>
+                  <a:srgbClr val="A0B4D2"/>
+                </a:solidFill>
+                <a:latin typeface="JetBrains Mono"/>
+              </a:rPr>
+              <a:t>VERSION</a:t>
+            </a:r>
+          </a:p>
+        </p:txBody>
+      </p:sp>
+      <p:sp>
+        <p:nvSpPr>
+          <p:cNvPr id="13" name="TextBox 12"/>
+          <p:cNvSpPr txBox="1"/>
+          <p:nvPr/>
+        </p:nvSpPr>
+        <p:spPr>
+          <a:xfrm>
+            <a:off x="7897368" y="5394960"/>
+            <a:ext cx="3605784" cy="320040"/>
+          </a:xfrm>
+          <a:prstGeom prst="rect">
+            <a:avLst/>
+          </a:prstGeom>
+          <a:noFill/>
+        </p:spPr>
+        <p:txBody>
+          <a:bodyPr wrap="square">
+            <a:spAutoFit/>
+          </a:bodyPr>
+          <a:lstStyle/>
+          <a:p>
+            <a:pPr algn="l"/>
+            <a:r>
+              <a:rPr sz="1100" b="0" i="0">
+                <a:solidFill>
+                  <a:srgbClr val="FFFFFF"/>
+                </a:solidFill>
+                <a:latin typeface="Arial"/>
+              </a:rPr>
+              <a:t>v0.3</a:t>
+            </a:r>
+          </a:p>
+        </p:txBody>
+      </p:sp>
+      <p:sp>
+        <p:nvSpPr>
+          <p:cNvPr id="14" name="Rectangle 13"/>
           <p:cNvSpPr/>
           <p:nvPr/>
         </p:nvSpPr>
@@ -4181,7 +4356,7 @@
       </p:sp>
       <p:sp>
         <p:nvSpPr>
-          <p:cNvPr id="10" name="TextBox 9"/>
+          <p:cNvPr id="15" name="TextBox 14"/>
           <p:cNvSpPr txBox="1"/>
           <p:nvPr/>
         </p:nvSpPr>
@@ -4216,7 +4391,7 @@
       </p:sp>
       <p:sp>
         <p:nvSpPr>
-          <p:cNvPr id="11" name="TextBox 10"/>
+          <p:cNvPr id="16" name="TextBox 15"/>
           <p:cNvSpPr txBox="1"/>
           <p:nvPr/>
         </p:nvSpPr>
@@ -5092,7 +5267,7 @@
                 </a:solidFill>
                 <a:latin typeface="Arial"/>
               </a:rPr>
-              <a:t>▸  Branchenspezifische Risikotreiber anhand von Finanzkennzahlen und Marktdaten analysieren und gegenüber gesamtwirtschaftlichen Trends einordnen (Bloom 4)</a:t>
+              <a:t>▸  Branchenspezifische Risikotreiber anhand von Finanzkennzahlen und Marktdaten analysieren und gegenüber gesamtwirtschaftlichen Trends einordnen</a:t>
             </a:r>
           </a:p>
           <a:p>
@@ -5111,7 +5286,7 @@
                 </a:solidFill>
                 <a:latin typeface="Arial"/>
               </a:rPr>
-              <a:t>▸  Das Gesamtrisikoprofil eines KMU durch kritische Gegenüberstellung von Branchencharakteristiken mit unternehmensspezifischen Kennzahlen bewerten (Bloom 5)</a:t>
+              <a:t>▸  Das Gesamtrisikoprofil eines KMU durch kritische Gegenüberstellung von Branchencharakteristiken mit unternehmensspezifischen Kennzahlen bewerten</a:t>
             </a:r>
           </a:p>
           <a:p>
@@ -5130,7 +5305,7 @@
                 </a:solidFill>
                 <a:latin typeface="Arial"/>
               </a:rPr>
-              <a:t>▸  Kreditanträge branchenübergreifend vergleichend beurteilen und Chancen wie Risiken transparent kommunizieren (Bloom 5)</a:t>
+              <a:t>▸  Kreditanträge branchenübergreifend vergleichend beurteilen und Chancen wie Risiken transparent kommunizieren</a:t>
             </a:r>
           </a:p>
           <a:p>
@@ -5149,7 +5324,7 @@
                 </a:solidFill>
                 <a:latin typeface="Arial"/>
               </a:rPr>
-              <a:t>▸  Ein individualisiertes Branchenrisiko-Scoring-Modell für die eigene Geschäftsregion entwickeln (Bloom 6)</a:t>
+              <a:t>▸  Ein individualisiertes Branchenrisiko-Scoring-Modell für die eigene Geschäftsregion entwickeln</a:t>
             </a:r>
           </a:p>
         </p:txBody>

</xml_diff>

<commit_message>
Framework-Grafiken-Namespace + 3 neue Handlungsempfehlung-Karten; Artefakte regeneriert
Co-Authored-By: Claude Fable 5 <noreply@anthropic.com>
</commit_message>
<xml_diff>
--- a/protected-downloads/praesentation/M05.pptx
+++ b/protected-downloads/praesentation/M05.pptx
@@ -15,6 +15,8 @@
     <p:sldId id="263" r:id="rId15"/>
     <p:sldId id="264" r:id="rId16"/>
     <p:sldId id="265" r:id="rId17"/>
+    <p:sldId id="266" r:id="rId18"/>
+    <p:sldId id="267" r:id="rId19"/>
   </p:sldIdLst>
   <p:sldSz cx="12188952" cy="6858000" type="screen4x3"/>
   <p:notesSz cx="6858000" cy="9144000"/>
@@ -817,6 +819,76 @@
 </file>
 
 <file path=ppt/notesSlides/notesSlide6.xml><?xml version="1.0" encoding="utf-8"?>
+<p:notes xmlns:a="http://schemas.openxmlformats.org/drawingml/2006/main" xmlns:p="http://schemas.openxmlformats.org/presentationml/2006/main" xmlns:r="http://schemas.openxmlformats.org/officeDocument/2006/relationships">
+  <p:cSld>
+    <p:spTree>
+      <p:nvGrpSpPr>
+        <p:cNvPr id="1" name=""/>
+        <p:cNvGrpSpPr/>
+        <p:nvPr/>
+      </p:nvGrpSpPr>
+      <p:grpSpPr>
+        <a:xfrm>
+          <a:off x="0" y="0"/>
+          <a:ext cx="0" cy="0"/>
+          <a:chOff x="0" y="0"/>
+          <a:chExt cx="0" cy="0"/>
+        </a:xfrm>
+      </p:grpSpPr>
+      <p:sp>
+        <p:nvSpPr>
+          <p:cNvPr id="2" name="Slide Image Placeholder 1"/>
+          <p:cNvSpPr>
+            <a:spLocks noGrp="1"/>
+          </p:cNvSpPr>
+          <p:nvPr>
+            <p:ph type="sldImg" idx="2"/>
+          </p:nvPr>
+        </p:nvSpPr>
+        <p:spPr/>
+      </p:sp>
+      <p:sp>
+        <p:nvSpPr>
+          <p:cNvPr id="3" name="Notes Placeholder 2"/>
+          <p:cNvSpPr>
+            <a:spLocks noGrp="1"/>
+          </p:cNvSpPr>
+          <p:nvPr>
+            <p:ph type="body" idx="3" sz="quarter"/>
+          </p:nvPr>
+        </p:nvSpPr>
+        <p:spPr/>
+        <p:txBody>
+          <a:bodyPr/>
+          <a:lstStyle/>
+          <a:p>
+            <a:r>
+              <a:t>Siehe Trainerhandbuch (Sektion 3) für Moderationshinweise, Timing und erwartete Teilnehmerreaktionen.</a:t>
+            </a:r>
+          </a:p>
+        </p:txBody>
+      </p:sp>
+      <p:sp>
+        <p:nvSpPr>
+          <p:cNvPr id="4" name="Slide Number Placeholder 3"/>
+          <p:cNvSpPr>
+            <a:spLocks noGrp="1"/>
+          </p:cNvSpPr>
+          <p:nvPr>
+            <p:ph type="sldNum" idx="5" sz="quarter"/>
+          </p:nvPr>
+        </p:nvSpPr>
+        <p:spPr/>
+      </p:sp>
+    </p:spTree>
+  </p:cSld>
+  <p:clrMapOvr>
+    <a:masterClrMapping/>
+  </p:clrMapOvr>
+</p:notes>
+</file>
+
+<file path=ppt/notesSlides/notesSlide7.xml><?xml version="1.0" encoding="utf-8"?>
 <p:notes xmlns:a="http://schemas.openxmlformats.org/drawingml/2006/main" xmlns:p="http://schemas.openxmlformats.org/presentationml/2006/main" xmlns:r="http://schemas.openxmlformats.org/officeDocument/2006/relationships">
   <p:cSld>
     <p:spTree>
@@ -4679,6 +4751,1184 @@
                 </a:solidFill>
                 <a:latin typeface="Source Serif 4"/>
               </a:rPr>
+              <a:t>Theorie-Input: VR-Rating und branchenspezifische Ratingfaktoren</a:t>
+            </a:r>
+          </a:p>
+        </p:txBody>
+      </p:sp>
+      <p:sp>
+        <p:nvSpPr>
+          <p:cNvPr id="8" name="TextBox 7"/>
+          <p:cNvSpPr txBox="1"/>
+          <p:nvPr/>
+        </p:nvSpPr>
+        <p:spPr>
+          <a:xfrm>
+            <a:off x="685800" y="1417320"/>
+            <a:ext cx="10817352" cy="5029200"/>
+          </a:xfrm>
+          <a:prstGeom prst="rect">
+            <a:avLst/>
+          </a:prstGeom>
+          <a:noFill/>
+        </p:spPr>
+        <p:txBody>
+          <a:bodyPr wrap="square">
+            <a:spAutoFit/>
+          </a:bodyPr>
+          <a:lstStyle/>
+          <a:p>
+            <a:pPr>
+              <a:spcBef>
+                <a:spcPts val="1000"/>
+              </a:spcBef>
+              <a:spcAft>
+                <a:spcPts val="200"/>
+              </a:spcAft>
+            </a:pPr>
+            <a:r>
+              <a:rPr sz="800" b="1">
+                <a:solidFill>
+                  <a:srgbClr val="78808C"/>
+                </a:solidFill>
+                <a:latin typeface="JetBrains Mono"/>
+              </a:rPr>
+              <a:t>4.3.1 AUFBAU DES VR-RATINGS</a:t>
+            </a:r>
+          </a:p>
+          <a:p>
+            <a:pPr>
+              <a:spcBef>
+                <a:spcPts val="400"/>
+              </a:spcBef>
+              <a:spcAft>
+                <a:spcPts val="200"/>
+              </a:spcAft>
+            </a:pPr>
+            <a:r>
+              <a:rPr sz="1200">
+                <a:solidFill>
+                  <a:srgbClr val="3D5466"/>
+                </a:solidFill>
+                <a:latin typeface="Arial"/>
+              </a:rPr>
+              <a:t>Das VR-Rating kombiniert quantitative und qualitative Komponenten:</a:t>
+            </a:r>
+          </a:p>
+          <a:p>
+            <a:pPr>
+              <a:spcBef>
+                <a:spcPts val="400"/>
+              </a:spcBef>
+              <a:spcAft>
+                <a:spcPts val="200"/>
+              </a:spcAft>
+            </a:pPr>
+            <a:r>
+              <a:rPr sz="1200">
+                <a:solidFill>
+                  <a:srgbClr val="3D5466"/>
+                </a:solidFill>
+                <a:latin typeface="Arial"/>
+              </a:rPr>
+              <a:t>Quantitativ (ca. 60–70 % Gewicht):</a:t>
+            </a:r>
+          </a:p>
+          <a:p>
+            <a:pPr>
+              <a:spcBef>
+                <a:spcPts val="400"/>
+              </a:spcBef>
+              <a:spcAft>
+                <a:spcPts val="200"/>
+              </a:spcAft>
+            </a:pPr>
+            <a:r>
+              <a:rPr sz="1300">
+                <a:solidFill>
+                  <a:srgbClr val="3D5466"/>
+                </a:solidFill>
+                <a:latin typeface="Arial"/>
+              </a:rPr>
+              <a:t>▸  Rentabilitätskennzahlen (EBIT-Marge, Eigenkapitalrentabilität)</a:t>
+            </a:r>
+          </a:p>
+          <a:p>
+            <a:pPr>
+              <a:spcBef>
+                <a:spcPts val="400"/>
+              </a:spcBef>
+              <a:spcAft>
+                <a:spcPts val="200"/>
+              </a:spcAft>
+            </a:pPr>
+            <a:r>
+              <a:rPr sz="1300">
+                <a:solidFill>
+                  <a:srgbClr val="3D5466"/>
+                </a:solidFill>
+                <a:latin typeface="Arial"/>
+              </a:rPr>
+              <a:t>▸  Liquiditätskennzahlen (Liquiditätsgrade, Cash-Flow-Relationen)</a:t>
+            </a:r>
+          </a:p>
+          <a:p>
+            <a:pPr>
+              <a:spcBef>
+                <a:spcPts val="400"/>
+              </a:spcBef>
+              <a:spcAft>
+                <a:spcPts val="200"/>
+              </a:spcAft>
+            </a:pPr>
+            <a:r>
+              <a:rPr sz="1300">
+                <a:solidFill>
+                  <a:srgbClr val="3D5466"/>
+                </a:solidFill>
+                <a:latin typeface="Arial"/>
+              </a:rPr>
+              <a:t>▸  Verschuldungskennzahlen (Eigenkapitalquote, Verschuldungsgrad, Zinsdeckungsquote)</a:t>
+            </a:r>
+          </a:p>
+          <a:p>
+            <a:pPr>
+              <a:spcBef>
+                <a:spcPts val="400"/>
+              </a:spcBef>
+              <a:spcAft>
+                <a:spcPts val="200"/>
+              </a:spcAft>
+            </a:pPr>
+            <a:r>
+              <a:rPr sz="1300">
+                <a:solidFill>
+                  <a:srgbClr val="3D5466"/>
+                </a:solidFill>
+                <a:latin typeface="Arial"/>
+              </a:rPr>
+              <a:t>▸  Trendindikatoren (Entwicklung über 3 Jahre)</a:t>
+            </a:r>
+          </a:p>
+          <a:p>
+            <a:pPr>
+              <a:spcBef>
+                <a:spcPts val="400"/>
+              </a:spcBef>
+              <a:spcAft>
+                <a:spcPts val="200"/>
+              </a:spcAft>
+            </a:pPr>
+            <a:r>
+              <a:rPr sz="1200">
+                <a:solidFill>
+                  <a:srgbClr val="3D5466"/>
+                </a:solidFill>
+                <a:latin typeface="Arial"/>
+              </a:rPr>
+              <a:t>Qualitativ (ca. 30–40 % Gewicht):</a:t>
+            </a:r>
+          </a:p>
+          <a:p>
+            <a:pPr>
+              <a:spcBef>
+                <a:spcPts val="400"/>
+              </a:spcBef>
+              <a:spcAft>
+                <a:spcPts val="200"/>
+              </a:spcAft>
+            </a:pPr>
+            <a:r>
+              <a:rPr sz="1300">
+                <a:solidFill>
+                  <a:srgbClr val="3D5466"/>
+                </a:solidFill>
+                <a:latin typeface="Arial"/>
+              </a:rPr>
+              <a:t>▸  Unternehmerqualität und Management-Kompetenz</a:t>
+            </a:r>
+          </a:p>
+          <a:p>
+            <a:pPr>
+              <a:spcBef>
+                <a:spcPts val="400"/>
+              </a:spcBef>
+              <a:spcAft>
+                <a:spcPts val="200"/>
+              </a:spcAft>
+            </a:pPr>
+            <a:r>
+              <a:rPr sz="1300">
+                <a:solidFill>
+                  <a:srgbClr val="3D5466"/>
+                </a:solidFill>
+                <a:latin typeface="Arial"/>
+              </a:rPr>
+              <a:t>▸  Branchenrisiko (Kerngegenstand dieses Moduls)</a:t>
+            </a:r>
+          </a:p>
+          <a:p>
+            <a:pPr>
+              <a:spcBef>
+                <a:spcPts val="400"/>
+              </a:spcBef>
+              <a:spcAft>
+                <a:spcPts val="200"/>
+              </a:spcAft>
+            </a:pPr>
+            <a:r>
+              <a:rPr sz="1300">
+                <a:solidFill>
+                  <a:srgbClr val="3D5466"/>
+                </a:solidFill>
+                <a:latin typeface="Arial"/>
+              </a:rPr>
+              <a:t>▸  Marktposition und Wettbewerbsfähigkeit</a:t>
+            </a:r>
+          </a:p>
+          <a:p>
+            <a:pPr>
+              <a:spcBef>
+                <a:spcPts val="400"/>
+              </a:spcBef>
+              <a:spcAft>
+                <a:spcPts val="200"/>
+              </a:spcAft>
+            </a:pPr>
+            <a:r>
+              <a:rPr sz="1300">
+                <a:solidFill>
+                  <a:srgbClr val="3D5466"/>
+                </a:solidFill>
+                <a:latin typeface="Arial"/>
+              </a:rPr>
+              <a:t>▸  Nachfolgeplanung (bei KMU kritisch)</a:t>
+            </a:r>
+          </a:p>
+        </p:txBody>
+      </p:sp>
+      <p:sp>
+        <p:nvSpPr>
+          <p:cNvPr id="9" name="Rectangle 8"/>
+          <p:cNvSpPr/>
+          <p:nvPr/>
+        </p:nvSpPr>
+        <p:spPr>
+          <a:xfrm>
+            <a:off x="0" y="6510528"/>
+            <a:ext cx="12188952" cy="347472"/>
+          </a:xfrm>
+          <a:prstGeom prst="rect">
+            <a:avLst/>
+          </a:prstGeom>
+          <a:solidFill>
+            <a:srgbClr val="0A1937"/>
+          </a:solidFill>
+          <a:ln>
+            <a:noFill/>
+          </a:ln>
+        </p:spPr>
+        <p:style>
+          <a:lnRef idx="1">
+            <a:schemeClr val="accent1"/>
+          </a:lnRef>
+          <a:fillRef idx="3">
+            <a:schemeClr val="accent1"/>
+          </a:fillRef>
+          <a:effectRef idx="2">
+            <a:schemeClr val="accent1"/>
+          </a:effectRef>
+          <a:fontRef idx="minor">
+            <a:schemeClr val="lt1"/>
+          </a:fontRef>
+        </p:style>
+        <p:txBody>
+          <a:bodyPr rtlCol="0" anchor="ctr"/>
+          <a:lstStyle/>
+          <a:p>
+            <a:pPr algn="ctr"/>
+          </a:p>
+        </p:txBody>
+      </p:sp>
+      <p:sp>
+        <p:nvSpPr>
+          <p:cNvPr id="10" name="TextBox 9"/>
+          <p:cNvSpPr txBox="1"/>
+          <p:nvPr/>
+        </p:nvSpPr>
+        <p:spPr>
+          <a:xfrm>
+            <a:off x="685800" y="6583680"/>
+            <a:ext cx="6490411" cy="256032"/>
+          </a:xfrm>
+          <a:prstGeom prst="rect">
+            <a:avLst/>
+          </a:prstGeom>
+          <a:noFill/>
+        </p:spPr>
+        <p:txBody>
+          <a:bodyPr wrap="none">
+            <a:spAutoFit/>
+          </a:bodyPr>
+          <a:lstStyle/>
+          <a:p>
+            <a:pPr algn="l"/>
+            <a:r>
+              <a:rPr sz="700">
+                <a:solidFill>
+                  <a:srgbClr val="A0B4D2"/>
+                </a:solidFill>
+                <a:latin typeface="JetBrains Mono"/>
+              </a:rPr>
+              <a:t>Benedikt Zoller Coaching  ·  FKB Campus  ·  M05</a:t>
+            </a:r>
+          </a:p>
+        </p:txBody>
+      </p:sp>
+    </p:spTree>
+  </p:cSld>
+  <p:clrMapOvr>
+    <a:masterClrMapping/>
+  </p:clrMapOvr>
+</p:sld>
+</file>
+
+<file path=ppt/slides/slide11.xml><?xml version="1.0" encoding="utf-8"?>
+<p:sld xmlns:a="http://schemas.openxmlformats.org/drawingml/2006/main" xmlns:p="http://schemas.openxmlformats.org/presentationml/2006/main" xmlns:r="http://schemas.openxmlformats.org/officeDocument/2006/relationships">
+  <p:cSld>
+    <p:spTree>
+      <p:nvGrpSpPr>
+        <p:cNvPr id="1" name=""/>
+        <p:cNvGrpSpPr/>
+        <p:nvPr/>
+      </p:nvGrpSpPr>
+      <p:grpSpPr/>
+      <p:sp>
+        <p:nvSpPr>
+          <p:cNvPr id="2" name="Rectangle 1"/>
+          <p:cNvSpPr/>
+          <p:nvPr/>
+        </p:nvSpPr>
+        <p:spPr>
+          <a:xfrm>
+            <a:off x="0" y="0"/>
+            <a:ext cx="12188952" cy="6858000"/>
+          </a:xfrm>
+          <a:prstGeom prst="rect">
+            <a:avLst/>
+          </a:prstGeom>
+          <a:solidFill>
+            <a:srgbClr val="EDEDF3"/>
+          </a:solidFill>
+          <a:ln>
+            <a:noFill/>
+          </a:ln>
+        </p:spPr>
+        <p:style>
+          <a:lnRef idx="1">
+            <a:schemeClr val="accent1"/>
+          </a:lnRef>
+          <a:fillRef idx="3">
+            <a:schemeClr val="accent1"/>
+          </a:fillRef>
+          <a:effectRef idx="2">
+            <a:schemeClr val="accent1"/>
+          </a:effectRef>
+          <a:fontRef idx="minor">
+            <a:schemeClr val="lt1"/>
+          </a:fontRef>
+        </p:style>
+        <p:txBody>
+          <a:bodyPr rtlCol="0" anchor="ctr"/>
+          <a:lstStyle/>
+          <a:p>
+            <a:pPr algn="ctr"/>
+          </a:p>
+        </p:txBody>
+      </p:sp>
+      <p:sp>
+        <p:nvSpPr>
+          <p:cNvPr id="3" name="Rectangle 2"/>
+          <p:cNvSpPr/>
+          <p:nvPr/>
+        </p:nvSpPr>
+        <p:spPr>
+          <a:xfrm>
+            <a:off x="0" y="0"/>
+            <a:ext cx="12188952" cy="50292"/>
+          </a:xfrm>
+          <a:prstGeom prst="rect">
+            <a:avLst/>
+          </a:prstGeom>
+          <a:solidFill>
+            <a:srgbClr val="1F2C56"/>
+          </a:solidFill>
+          <a:ln>
+            <a:noFill/>
+          </a:ln>
+        </p:spPr>
+        <p:style>
+          <a:lnRef idx="1">
+            <a:schemeClr val="accent1"/>
+          </a:lnRef>
+          <a:fillRef idx="3">
+            <a:schemeClr val="accent1"/>
+          </a:fillRef>
+          <a:effectRef idx="2">
+            <a:schemeClr val="accent1"/>
+          </a:effectRef>
+          <a:fontRef idx="minor">
+            <a:schemeClr val="lt1"/>
+          </a:fontRef>
+        </p:style>
+        <p:txBody>
+          <a:bodyPr rtlCol="0" anchor="ctr"/>
+          <a:lstStyle/>
+          <a:p>
+            <a:pPr algn="ctr"/>
+          </a:p>
+        </p:txBody>
+      </p:sp>
+      <p:sp>
+        <p:nvSpPr>
+          <p:cNvPr id="4" name="TextBox 3"/>
+          <p:cNvSpPr txBox="1"/>
+          <p:nvPr/>
+        </p:nvSpPr>
+        <p:spPr>
+          <a:xfrm>
+            <a:off x="685800" y="109728"/>
+            <a:ext cx="10817352" cy="228600"/>
+          </a:xfrm>
+          <a:prstGeom prst="rect">
+            <a:avLst/>
+          </a:prstGeom>
+          <a:noFill/>
+        </p:spPr>
+        <p:txBody>
+          <a:bodyPr wrap="none">
+            <a:spAutoFit/>
+          </a:bodyPr>
+          <a:lstStyle/>
+          <a:p>
+            <a:pPr algn="l"/>
+            <a:r>
+              <a:rPr sz="750">
+                <a:solidFill>
+                  <a:srgbClr val="78808C"/>
+                </a:solidFill>
+                <a:latin typeface="JetBrains Mono"/>
+              </a:rPr>
+              <a:t>M05  ·  INHALT</a:t>
+            </a:r>
+          </a:p>
+        </p:txBody>
+      </p:sp>
+      <p:sp>
+        <p:nvSpPr>
+          <p:cNvPr id="5" name="Rectangle 4"/>
+          <p:cNvSpPr/>
+          <p:nvPr/>
+        </p:nvSpPr>
+        <p:spPr>
+          <a:xfrm>
+            <a:off x="0" y="1234440"/>
+            <a:ext cx="12188952" cy="12700"/>
+          </a:xfrm>
+          <a:prstGeom prst="rect">
+            <a:avLst/>
+          </a:prstGeom>
+          <a:solidFill>
+            <a:srgbClr val="D8DFE4"/>
+          </a:solidFill>
+          <a:ln>
+            <a:noFill/>
+          </a:ln>
+        </p:spPr>
+        <p:style>
+          <a:lnRef idx="1">
+            <a:schemeClr val="accent1"/>
+          </a:lnRef>
+          <a:fillRef idx="3">
+            <a:schemeClr val="accent1"/>
+          </a:fillRef>
+          <a:effectRef idx="2">
+            <a:schemeClr val="accent1"/>
+          </a:effectRef>
+          <a:fontRef idx="minor">
+            <a:schemeClr val="lt1"/>
+          </a:fontRef>
+        </p:style>
+        <p:txBody>
+          <a:bodyPr rtlCol="0" anchor="ctr"/>
+          <a:lstStyle/>
+          <a:p>
+            <a:pPr algn="ctr"/>
+          </a:p>
+        </p:txBody>
+      </p:sp>
+      <p:sp>
+        <p:nvSpPr>
+          <p:cNvPr id="6" name="Rectangle 5"/>
+          <p:cNvSpPr/>
+          <p:nvPr/>
+        </p:nvSpPr>
+        <p:spPr>
+          <a:xfrm>
+            <a:off x="685800" y="502920"/>
+            <a:ext cx="36576" cy="658368"/>
+          </a:xfrm>
+          <a:prstGeom prst="rect">
+            <a:avLst/>
+          </a:prstGeom>
+          <a:solidFill>
+            <a:srgbClr val="D9C089"/>
+          </a:solidFill>
+          <a:ln>
+            <a:noFill/>
+          </a:ln>
+        </p:spPr>
+        <p:style>
+          <a:lnRef idx="1">
+            <a:schemeClr val="accent1"/>
+          </a:lnRef>
+          <a:fillRef idx="3">
+            <a:schemeClr val="accent1"/>
+          </a:fillRef>
+          <a:effectRef idx="2">
+            <a:schemeClr val="accent1"/>
+          </a:effectRef>
+          <a:fontRef idx="minor">
+            <a:schemeClr val="lt1"/>
+          </a:fontRef>
+        </p:style>
+        <p:txBody>
+          <a:bodyPr rtlCol="0" anchor="ctr"/>
+          <a:lstStyle/>
+          <a:p>
+            <a:pPr algn="ctr"/>
+          </a:p>
+        </p:txBody>
+      </p:sp>
+      <p:sp>
+        <p:nvSpPr>
+          <p:cNvPr id="7" name="TextBox 6"/>
+          <p:cNvSpPr txBox="1"/>
+          <p:nvPr/>
+        </p:nvSpPr>
+        <p:spPr>
+          <a:xfrm>
+            <a:off x="813816" y="502920"/>
+            <a:ext cx="10634472" cy="685800"/>
+          </a:xfrm>
+          <a:prstGeom prst="rect">
+            <a:avLst/>
+          </a:prstGeom>
+          <a:noFill/>
+        </p:spPr>
+        <p:txBody>
+          <a:bodyPr wrap="square">
+            <a:spAutoFit/>
+          </a:bodyPr>
+          <a:lstStyle/>
+          <a:p>
+            <a:pPr algn="l"/>
+            <a:r>
+              <a:rPr sz="2400" b="1" i="0">
+                <a:solidFill>
+                  <a:srgbClr val="1F2C56"/>
+                </a:solidFill>
+                <a:latin typeface="Source Serif 4"/>
+              </a:rPr>
+              <a:t>Praxiscase: Bäckerei &amp; Konditorei Hofmann GmbH (Stuttgart, fiktiv)</a:t>
+            </a:r>
+          </a:p>
+        </p:txBody>
+      </p:sp>
+      <p:sp>
+        <p:nvSpPr>
+          <p:cNvPr id="8" name="TextBox 7"/>
+          <p:cNvSpPr txBox="1"/>
+          <p:nvPr/>
+        </p:nvSpPr>
+        <p:spPr>
+          <a:xfrm>
+            <a:off x="685800" y="1417320"/>
+            <a:ext cx="10817352" cy="5029200"/>
+          </a:xfrm>
+          <a:prstGeom prst="rect">
+            <a:avLst/>
+          </a:prstGeom>
+          <a:noFill/>
+        </p:spPr>
+        <p:txBody>
+          <a:bodyPr wrap="square">
+            <a:spAutoFit/>
+          </a:bodyPr>
+          <a:lstStyle/>
+          <a:p>
+            <a:pPr>
+              <a:spcBef>
+                <a:spcPts val="1000"/>
+              </a:spcBef>
+              <a:spcAft>
+                <a:spcPts val="200"/>
+              </a:spcAft>
+            </a:pPr>
+            <a:r>
+              <a:rPr sz="800" b="1">
+                <a:solidFill>
+                  <a:srgbClr val="78808C"/>
+                </a:solidFill>
+                <a:latin typeface="JetBrains Mono"/>
+              </a:rPr>
+              <a:t>4.4.1 UNTERNEHMENSPROFIL</a:t>
+            </a:r>
+          </a:p>
+          <a:p>
+            <a:pPr>
+              <a:spcBef>
+                <a:spcPts val="1000"/>
+              </a:spcBef>
+              <a:spcAft>
+                <a:spcPts val="200"/>
+              </a:spcAft>
+            </a:pPr>
+            <a:r>
+              <a:rPr sz="800" b="1">
+                <a:solidFill>
+                  <a:srgbClr val="78808C"/>
+                </a:solidFill>
+                <a:latin typeface="JetBrains Mono"/>
+              </a:rPr>
+              <a:t>4.4.2 FINANZIELLE SITUATION (JAHRESABSCHLUSS 2024, AUSZÜGE)</a:t>
+            </a:r>
+          </a:p>
+          <a:p>
+            <a:pPr>
+              <a:spcBef>
+                <a:spcPts val="400"/>
+              </a:spcBef>
+              <a:spcAft>
+                <a:spcPts val="200"/>
+              </a:spcAft>
+            </a:pPr>
+            <a:r>
+              <a:rPr sz="1200">
+                <a:solidFill>
+                  <a:srgbClr val="3D5466"/>
+                </a:solidFill>
+                <a:latin typeface="Arial"/>
+              </a:rPr>
+              <a:t>Bilanzauszug:</a:t>
+            </a:r>
+          </a:p>
+          <a:p>
+            <a:pPr>
+              <a:spcBef>
+                <a:spcPts val="400"/>
+              </a:spcBef>
+              <a:spcAft>
+                <a:spcPts val="200"/>
+              </a:spcAft>
+            </a:pPr>
+            <a:r>
+              <a:rPr sz="1200">
+                <a:solidFill>
+                  <a:srgbClr val="3D5466"/>
+                </a:solidFill>
+                <a:latin typeface="Arial"/>
+              </a:rPr>
+              <a:t>Gewinn- und Verlustrechnung 2024:</a:t>
+            </a:r>
+          </a:p>
+          <a:p>
+            <a:pPr>
+              <a:spcBef>
+                <a:spcPts val="400"/>
+              </a:spcBef>
+              <a:spcAft>
+                <a:spcPts val="200"/>
+              </a:spcAft>
+            </a:pPr>
+            <a:r>
+              <a:rPr sz="1200">
+                <a:solidFill>
+                  <a:srgbClr val="3D5466"/>
+                </a:solidFill>
+                <a:latin typeface="Arial"/>
+              </a:rPr>
+              <a:t>Kapitalflussrechnung 2024 (vereinfacht):</a:t>
+            </a:r>
+          </a:p>
+          <a:p>
+            <a:pPr>
+              <a:spcBef>
+                <a:spcPts val="1000"/>
+              </a:spcBef>
+              <a:spcAft>
+                <a:spcPts val="200"/>
+              </a:spcAft>
+            </a:pPr>
+            <a:r>
+              <a:rPr sz="800" b="1">
+                <a:solidFill>
+                  <a:srgbClr val="78808C"/>
+                </a:solidFill>
+                <a:latin typeface="JetBrains Mono"/>
+              </a:rPr>
+              <a:t>4.4.3 KREDITANFRAGE</a:t>
+            </a:r>
+          </a:p>
+          <a:p>
+            <a:pPr>
+              <a:spcBef>
+                <a:spcPts val="400"/>
+              </a:spcBef>
+              <a:spcAft>
+                <a:spcPts val="200"/>
+              </a:spcAft>
+            </a:pPr>
+            <a:r>
+              <a:rPr sz="1200">
+                <a:solidFill>
+                  <a:srgbClr val="3D5466"/>
+                </a:solidFill>
+                <a:latin typeface="Arial"/>
+              </a:rPr>
+              <a:t>Anlass: Investition in neue Backstube Kempten-Süd (170.000 €) + Filialmodernisierung Sonthofen (80.000 €)</a:t>
+            </a:r>
+          </a:p>
+          <a:p>
+            <a:pPr>
+              <a:spcBef>
+                <a:spcPts val="400"/>
+              </a:spcBef>
+              <a:spcAft>
+                <a:spcPts val="200"/>
+              </a:spcAft>
+            </a:pPr>
+            <a:r>
+              <a:rPr sz="1200">
+                <a:solidFill>
+                  <a:srgbClr val="3D5466"/>
+                </a:solidFill>
+                <a:latin typeface="Arial"/>
+              </a:rPr>
+              <a:t>Gesamtkreditbedarf: 250.000 € | Eigenanteil: 30.000 € | Kreditwunsch: 250.000 €</a:t>
+            </a:r>
+          </a:p>
+          <a:p>
+            <a:pPr>
+              <a:spcBef>
+                <a:spcPts val="1000"/>
+              </a:spcBef>
+              <a:spcAft>
+                <a:spcPts val="200"/>
+              </a:spcAft>
+            </a:pPr>
+            <a:r>
+              <a:rPr sz="800" b="1">
+                <a:solidFill>
+                  <a:srgbClr val="78808C"/>
+                </a:solidFill>
+                <a:latin typeface="JetBrains Mono"/>
+              </a:rPr>
+              <a:t>4.4.4 GESPRÄCHSVERLAUF: BRANCHENRISIKOANALYSE (BER = BERATER, GF = GESCHÄFTSFÜHRERIN)</a:t>
+            </a:r>
+          </a:p>
+          <a:p>
+            <a:pPr>
+              <a:spcBef>
+                <a:spcPts val="400"/>
+              </a:spcBef>
+              <a:spcAft>
+                <a:spcPts val="200"/>
+              </a:spcAft>
+            </a:pPr>
+            <a:r>
+              <a:rPr sz="1200">
+                <a:solidFill>
+                  <a:srgbClr val="3D5466"/>
+                </a:solidFill>
+                <a:latin typeface="Arial"/>
+              </a:rPr>
+              <a:t>Session 1 – Erstgespräch Branchenrisiko</a:t>
+            </a:r>
+          </a:p>
+          <a:p>
+            <a:pPr>
+              <a:spcBef>
+                <a:spcPts val="400"/>
+              </a:spcBef>
+              <a:spcAft>
+                <a:spcPts val="200"/>
+              </a:spcAft>
+            </a:pPr>
+            <a:r>
+              <a:rPr sz="1200">
+                <a:solidFill>
+                  <a:srgbClr val="3D5466"/>
+                </a:solidFill>
+                <a:latin typeface="Arial"/>
+              </a:rPr>
+              <a:t>GF: „Wir konnten die Preise nur um etwa 8–10 % erhöhen, ohne Kunden zu verlieren. Das hat die Marge deutlich gedrückt."</a:t>
+            </a:r>
+          </a:p>
+          <a:p>
+            <a:pPr>
+              <a:spcBef>
+                <a:spcPts val="400"/>
+              </a:spcBef>
+              <a:spcAft>
+                <a:spcPts val="200"/>
+              </a:spcAft>
+            </a:pPr>
+            <a:r>
+              <a:rPr sz="1200">
+                <a:solidFill>
+                  <a:srgbClr val="3D5466"/>
+                </a:solidFill>
+                <a:latin typeface="Arial"/>
+              </a:rPr>
+              <a:t>GF: „Nein, wir kaufen zu aktuellen Marktpreisen. Die Lieferanten bieten keine Festpreise an."</a:t>
+            </a:r>
+          </a:p>
+        </p:txBody>
+      </p:sp>
+      <p:sp>
+        <p:nvSpPr>
+          <p:cNvPr id="9" name="Rectangle 8"/>
+          <p:cNvSpPr/>
+          <p:nvPr/>
+        </p:nvSpPr>
+        <p:spPr>
+          <a:xfrm>
+            <a:off x="0" y="6510528"/>
+            <a:ext cx="12188952" cy="347472"/>
+          </a:xfrm>
+          <a:prstGeom prst="rect">
+            <a:avLst/>
+          </a:prstGeom>
+          <a:solidFill>
+            <a:srgbClr val="0A1937"/>
+          </a:solidFill>
+          <a:ln>
+            <a:noFill/>
+          </a:ln>
+        </p:spPr>
+        <p:style>
+          <a:lnRef idx="1">
+            <a:schemeClr val="accent1"/>
+          </a:lnRef>
+          <a:fillRef idx="3">
+            <a:schemeClr val="accent1"/>
+          </a:fillRef>
+          <a:effectRef idx="2">
+            <a:schemeClr val="accent1"/>
+          </a:effectRef>
+          <a:fontRef idx="minor">
+            <a:schemeClr val="lt1"/>
+          </a:fontRef>
+        </p:style>
+        <p:txBody>
+          <a:bodyPr rtlCol="0" anchor="ctr"/>
+          <a:lstStyle/>
+          <a:p>
+            <a:pPr algn="ctr"/>
+          </a:p>
+        </p:txBody>
+      </p:sp>
+      <p:sp>
+        <p:nvSpPr>
+          <p:cNvPr id="10" name="TextBox 9"/>
+          <p:cNvSpPr txBox="1"/>
+          <p:nvPr/>
+        </p:nvSpPr>
+        <p:spPr>
+          <a:xfrm>
+            <a:off x="685800" y="6583680"/>
+            <a:ext cx="6490411" cy="256032"/>
+          </a:xfrm>
+          <a:prstGeom prst="rect">
+            <a:avLst/>
+          </a:prstGeom>
+          <a:noFill/>
+        </p:spPr>
+        <p:txBody>
+          <a:bodyPr wrap="none">
+            <a:spAutoFit/>
+          </a:bodyPr>
+          <a:lstStyle/>
+          <a:p>
+            <a:pPr algn="l"/>
+            <a:r>
+              <a:rPr sz="700">
+                <a:solidFill>
+                  <a:srgbClr val="A0B4D2"/>
+                </a:solidFill>
+                <a:latin typeface="JetBrains Mono"/>
+              </a:rPr>
+              <a:t>Benedikt Zoller Coaching  ·  FKB Campus  ·  M05</a:t>
+            </a:r>
+          </a:p>
+        </p:txBody>
+      </p:sp>
+    </p:spTree>
+  </p:cSld>
+  <p:clrMapOvr>
+    <a:masterClrMapping/>
+  </p:clrMapOvr>
+</p:sld>
+</file>
+
+<file path=ppt/slides/slide12.xml><?xml version="1.0" encoding="utf-8"?>
+<p:sld xmlns:a="http://schemas.openxmlformats.org/drawingml/2006/main" xmlns:p="http://schemas.openxmlformats.org/presentationml/2006/main" xmlns:r="http://schemas.openxmlformats.org/officeDocument/2006/relationships">
+  <p:cSld>
+    <p:spTree>
+      <p:nvGrpSpPr>
+        <p:cNvPr id="1" name=""/>
+        <p:cNvGrpSpPr/>
+        <p:nvPr/>
+      </p:nvGrpSpPr>
+      <p:grpSpPr/>
+      <p:sp>
+        <p:nvSpPr>
+          <p:cNvPr id="2" name="Rectangle 1"/>
+          <p:cNvSpPr/>
+          <p:nvPr/>
+        </p:nvSpPr>
+        <p:spPr>
+          <a:xfrm>
+            <a:off x="0" y="0"/>
+            <a:ext cx="12188952" cy="6858000"/>
+          </a:xfrm>
+          <a:prstGeom prst="rect">
+            <a:avLst/>
+          </a:prstGeom>
+          <a:solidFill>
+            <a:srgbClr val="EDEDF3"/>
+          </a:solidFill>
+          <a:ln>
+            <a:noFill/>
+          </a:ln>
+        </p:spPr>
+        <p:style>
+          <a:lnRef idx="1">
+            <a:schemeClr val="accent1"/>
+          </a:lnRef>
+          <a:fillRef idx="3">
+            <a:schemeClr val="accent1"/>
+          </a:fillRef>
+          <a:effectRef idx="2">
+            <a:schemeClr val="accent1"/>
+          </a:effectRef>
+          <a:fontRef idx="minor">
+            <a:schemeClr val="lt1"/>
+          </a:fontRef>
+        </p:style>
+        <p:txBody>
+          <a:bodyPr rtlCol="0" anchor="ctr"/>
+          <a:lstStyle/>
+          <a:p>
+            <a:pPr algn="ctr"/>
+          </a:p>
+        </p:txBody>
+      </p:sp>
+      <p:sp>
+        <p:nvSpPr>
+          <p:cNvPr id="3" name="Rectangle 2"/>
+          <p:cNvSpPr/>
+          <p:nvPr/>
+        </p:nvSpPr>
+        <p:spPr>
+          <a:xfrm>
+            <a:off x="0" y="0"/>
+            <a:ext cx="12188952" cy="50292"/>
+          </a:xfrm>
+          <a:prstGeom prst="rect">
+            <a:avLst/>
+          </a:prstGeom>
+          <a:solidFill>
+            <a:srgbClr val="1F2C56"/>
+          </a:solidFill>
+          <a:ln>
+            <a:noFill/>
+          </a:ln>
+        </p:spPr>
+        <p:style>
+          <a:lnRef idx="1">
+            <a:schemeClr val="accent1"/>
+          </a:lnRef>
+          <a:fillRef idx="3">
+            <a:schemeClr val="accent1"/>
+          </a:fillRef>
+          <a:effectRef idx="2">
+            <a:schemeClr val="accent1"/>
+          </a:effectRef>
+          <a:fontRef idx="minor">
+            <a:schemeClr val="lt1"/>
+          </a:fontRef>
+        </p:style>
+        <p:txBody>
+          <a:bodyPr rtlCol="0" anchor="ctr"/>
+          <a:lstStyle/>
+          <a:p>
+            <a:pPr algn="ctr"/>
+          </a:p>
+        </p:txBody>
+      </p:sp>
+      <p:sp>
+        <p:nvSpPr>
+          <p:cNvPr id="4" name="TextBox 3"/>
+          <p:cNvSpPr txBox="1"/>
+          <p:nvPr/>
+        </p:nvSpPr>
+        <p:spPr>
+          <a:xfrm>
+            <a:off x="685800" y="109728"/>
+            <a:ext cx="10817352" cy="228600"/>
+          </a:xfrm>
+          <a:prstGeom prst="rect">
+            <a:avLst/>
+          </a:prstGeom>
+          <a:noFill/>
+        </p:spPr>
+        <p:txBody>
+          <a:bodyPr wrap="none">
+            <a:spAutoFit/>
+          </a:bodyPr>
+          <a:lstStyle/>
+          <a:p>
+            <a:pPr algn="l"/>
+            <a:r>
+              <a:rPr sz="750">
+                <a:solidFill>
+                  <a:srgbClr val="78808C"/>
+                </a:solidFill>
+                <a:latin typeface="JetBrains Mono"/>
+              </a:rPr>
+              <a:t>M05  ·  INHALT</a:t>
+            </a:r>
+          </a:p>
+        </p:txBody>
+      </p:sp>
+      <p:sp>
+        <p:nvSpPr>
+          <p:cNvPr id="5" name="Rectangle 4"/>
+          <p:cNvSpPr/>
+          <p:nvPr/>
+        </p:nvSpPr>
+        <p:spPr>
+          <a:xfrm>
+            <a:off x="0" y="1234440"/>
+            <a:ext cx="12188952" cy="12700"/>
+          </a:xfrm>
+          <a:prstGeom prst="rect">
+            <a:avLst/>
+          </a:prstGeom>
+          <a:solidFill>
+            <a:srgbClr val="D8DFE4"/>
+          </a:solidFill>
+          <a:ln>
+            <a:noFill/>
+          </a:ln>
+        </p:spPr>
+        <p:style>
+          <a:lnRef idx="1">
+            <a:schemeClr val="accent1"/>
+          </a:lnRef>
+          <a:fillRef idx="3">
+            <a:schemeClr val="accent1"/>
+          </a:fillRef>
+          <a:effectRef idx="2">
+            <a:schemeClr val="accent1"/>
+          </a:effectRef>
+          <a:fontRef idx="minor">
+            <a:schemeClr val="lt1"/>
+          </a:fontRef>
+        </p:style>
+        <p:txBody>
+          <a:bodyPr rtlCol="0" anchor="ctr"/>
+          <a:lstStyle/>
+          <a:p>
+            <a:pPr algn="ctr"/>
+          </a:p>
+        </p:txBody>
+      </p:sp>
+      <p:sp>
+        <p:nvSpPr>
+          <p:cNvPr id="6" name="Rectangle 5"/>
+          <p:cNvSpPr/>
+          <p:nvPr/>
+        </p:nvSpPr>
+        <p:spPr>
+          <a:xfrm>
+            <a:off x="685800" y="502920"/>
+            <a:ext cx="36576" cy="658368"/>
+          </a:xfrm>
+          <a:prstGeom prst="rect">
+            <a:avLst/>
+          </a:prstGeom>
+          <a:solidFill>
+            <a:srgbClr val="D9C089"/>
+          </a:solidFill>
+          <a:ln>
+            <a:noFill/>
+          </a:ln>
+        </p:spPr>
+        <p:style>
+          <a:lnRef idx="1">
+            <a:schemeClr val="accent1"/>
+          </a:lnRef>
+          <a:fillRef idx="3">
+            <a:schemeClr val="accent1"/>
+          </a:fillRef>
+          <a:effectRef idx="2">
+            <a:schemeClr val="accent1"/>
+          </a:effectRef>
+          <a:fontRef idx="minor">
+            <a:schemeClr val="lt1"/>
+          </a:fontRef>
+        </p:style>
+        <p:txBody>
+          <a:bodyPr rtlCol="0" anchor="ctr"/>
+          <a:lstStyle/>
+          <a:p>
+            <a:pPr algn="ctr"/>
+          </a:p>
+        </p:txBody>
+      </p:sp>
+      <p:sp>
+        <p:nvSpPr>
+          <p:cNvPr id="7" name="TextBox 6"/>
+          <p:cNvSpPr txBox="1"/>
+          <p:nvPr/>
+        </p:nvSpPr>
+        <p:spPr>
+          <a:xfrm>
+            <a:off x="813816" y="502920"/>
+            <a:ext cx="10634472" cy="685800"/>
+          </a:xfrm>
+          <a:prstGeom prst="rect">
+            <a:avLst/>
+          </a:prstGeom>
+          <a:noFill/>
+        </p:spPr>
+        <p:txBody>
+          <a:bodyPr wrap="square">
+            <a:spAutoFit/>
+          </a:bodyPr>
+          <a:lstStyle/>
+          <a:p>
+            <a:pPr algn="l"/>
+            <a:r>
+              <a:rPr sz="2400" b="1" i="0">
+                <a:solidFill>
+                  <a:srgbClr val="1F2C56"/>
+                </a:solidFill>
+                <a:latin typeface="Source Serif 4"/>
+              </a:rPr>
               <a:t>Arbeitsblatt: Branchenrisiko-Analyse-Template</a:t>
             </a:r>
           </a:p>
@@ -5699,7 +6949,7 @@
                 </a:solidFill>
                 <a:latin typeface="Arial"/>
               </a:rPr>
-              <a:t>03   Theorie-Input: VR-Rating und branchenspezifische Ratingfaktoren</a:t>
+              <a:t>03   Handlungskarte: Vom Branchensignal zur Kreditmaßnahme</a:t>
             </a:r>
           </a:p>
           <a:p>
@@ -5718,7 +6968,7 @@
                 </a:solidFill>
                 <a:latin typeface="Arial"/>
               </a:rPr>
-              <a:t>04   Praxiscase: Bäckerei &amp; Konditorei Hofmann GmbH (Stuttgart, fiktiv)</a:t>
+              <a:t>04   Theorie-Input: VR-Rating und branchenspezifische Ratingfaktoren</a:t>
             </a:r>
           </a:p>
           <a:p>
@@ -5737,7 +6987,26 @@
                 </a:solidFill>
                 <a:latin typeface="Arial"/>
               </a:rPr>
-              <a:t>05   Arbeitsblatt: Branchenrisiko-Analyse-Template</a:t>
+              <a:t>05   Praxiscase: Bäckerei &amp; Konditorei Hofmann GmbH (Stuttgart, fiktiv)</a:t>
+            </a:r>
+          </a:p>
+          <a:p>
+            <a:pPr>
+              <a:spcBef>
+                <a:spcPts val="800"/>
+              </a:spcBef>
+              <a:spcAft>
+                <a:spcPts val="200"/>
+              </a:spcAft>
+            </a:pPr>
+            <a:r>
+              <a:rPr sz="1500">
+                <a:solidFill>
+                  <a:srgbClr val="3D5466"/>
+                </a:solidFill>
+                <a:latin typeface="Arial"/>
+              </a:rPr>
+              <a:t>06   Arbeitsblatt: Branchenrisiko-Analyse-Template</a:t>
             </a:r>
           </a:p>
         </p:txBody>
@@ -7961,7 +9230,7 @@
                 </a:solidFill>
                 <a:latin typeface="Source Serif 4"/>
               </a:rPr>
-              <a:t>Theorie-Input: VR-Rating und branchenspezifische Ratingfaktoren</a:t>
+              <a:t>Handlungskarte: Vom Branchensignal zur Kreditmaßnahme</a:t>
             </a:r>
           </a:p>
         </p:txBody>
@@ -7987,25 +9256,6 @@
             <a:spAutoFit/>
           </a:bodyPr>
           <a:lstStyle/>
-          <a:p>
-            <a:pPr>
-              <a:spcBef>
-                <a:spcPts val="1000"/>
-              </a:spcBef>
-              <a:spcAft>
-                <a:spcPts val="200"/>
-              </a:spcAft>
-            </a:pPr>
-            <a:r>
-              <a:rPr sz="800" b="1">
-                <a:solidFill>
-                  <a:srgbClr val="78808C"/>
-                </a:solidFill>
-                <a:latin typeface="JetBrains Mono"/>
-              </a:rPr>
-              <a:t>4.3.1 AUFBAU DES VR-RATINGS</a:t>
-            </a:r>
-          </a:p>
           <a:p>
             <a:pPr>
               <a:spcBef>
@@ -8022,197 +9272,7 @@
                 </a:solidFill>
                 <a:latin typeface="Arial"/>
               </a:rPr>
-              <a:t>Das VR-Rating kombiniert quantitative und qualitative Komponenten:</a:t>
-            </a:r>
-          </a:p>
-          <a:p>
-            <a:pPr>
-              <a:spcBef>
-                <a:spcPts val="400"/>
-              </a:spcBef>
-              <a:spcAft>
-                <a:spcPts val="200"/>
-              </a:spcAft>
-            </a:pPr>
-            <a:r>
-              <a:rPr sz="1200">
-                <a:solidFill>
-                  <a:srgbClr val="3D5466"/>
-                </a:solidFill>
-                <a:latin typeface="Arial"/>
-              </a:rPr>
-              <a:t>Quantitativ (ca. 60–70 % Gewicht):</a:t>
-            </a:r>
-          </a:p>
-          <a:p>
-            <a:pPr>
-              <a:spcBef>
-                <a:spcPts val="400"/>
-              </a:spcBef>
-              <a:spcAft>
-                <a:spcPts val="200"/>
-              </a:spcAft>
-            </a:pPr>
-            <a:r>
-              <a:rPr sz="1300">
-                <a:solidFill>
-                  <a:srgbClr val="3D5466"/>
-                </a:solidFill>
-                <a:latin typeface="Arial"/>
-              </a:rPr>
-              <a:t>▸  Rentabilitätskennzahlen (EBIT-Marge, Eigenkapitalrentabilität)</a:t>
-            </a:r>
-          </a:p>
-          <a:p>
-            <a:pPr>
-              <a:spcBef>
-                <a:spcPts val="400"/>
-              </a:spcBef>
-              <a:spcAft>
-                <a:spcPts val="200"/>
-              </a:spcAft>
-            </a:pPr>
-            <a:r>
-              <a:rPr sz="1300">
-                <a:solidFill>
-                  <a:srgbClr val="3D5466"/>
-                </a:solidFill>
-                <a:latin typeface="Arial"/>
-              </a:rPr>
-              <a:t>▸  Liquiditätskennzahlen (Liquiditätsgrade, Cash-Flow-Relationen)</a:t>
-            </a:r>
-          </a:p>
-          <a:p>
-            <a:pPr>
-              <a:spcBef>
-                <a:spcPts val="400"/>
-              </a:spcBef>
-              <a:spcAft>
-                <a:spcPts val="200"/>
-              </a:spcAft>
-            </a:pPr>
-            <a:r>
-              <a:rPr sz="1300">
-                <a:solidFill>
-                  <a:srgbClr val="3D5466"/>
-                </a:solidFill>
-                <a:latin typeface="Arial"/>
-              </a:rPr>
-              <a:t>▸  Verschuldungskennzahlen (Eigenkapitalquote, Verschuldungsgrad, Zinsdeckungsquote)</a:t>
-            </a:r>
-          </a:p>
-          <a:p>
-            <a:pPr>
-              <a:spcBef>
-                <a:spcPts val="400"/>
-              </a:spcBef>
-              <a:spcAft>
-                <a:spcPts val="200"/>
-              </a:spcAft>
-            </a:pPr>
-            <a:r>
-              <a:rPr sz="1300">
-                <a:solidFill>
-                  <a:srgbClr val="3D5466"/>
-                </a:solidFill>
-                <a:latin typeface="Arial"/>
-              </a:rPr>
-              <a:t>▸  Trendindikatoren (Entwicklung über 3 Jahre)</a:t>
-            </a:r>
-          </a:p>
-          <a:p>
-            <a:pPr>
-              <a:spcBef>
-                <a:spcPts val="400"/>
-              </a:spcBef>
-              <a:spcAft>
-                <a:spcPts val="200"/>
-              </a:spcAft>
-            </a:pPr>
-            <a:r>
-              <a:rPr sz="1200">
-                <a:solidFill>
-                  <a:srgbClr val="3D5466"/>
-                </a:solidFill>
-                <a:latin typeface="Arial"/>
-              </a:rPr>
-              <a:t>Qualitativ (ca. 30–40 % Gewicht):</a:t>
-            </a:r>
-          </a:p>
-          <a:p>
-            <a:pPr>
-              <a:spcBef>
-                <a:spcPts val="400"/>
-              </a:spcBef>
-              <a:spcAft>
-                <a:spcPts val="200"/>
-              </a:spcAft>
-            </a:pPr>
-            <a:r>
-              <a:rPr sz="1300">
-                <a:solidFill>
-                  <a:srgbClr val="3D5466"/>
-                </a:solidFill>
-                <a:latin typeface="Arial"/>
-              </a:rPr>
-              <a:t>▸  Unternehmerqualität und Management-Kompetenz</a:t>
-            </a:r>
-          </a:p>
-          <a:p>
-            <a:pPr>
-              <a:spcBef>
-                <a:spcPts val="400"/>
-              </a:spcBef>
-              <a:spcAft>
-                <a:spcPts val="200"/>
-              </a:spcAft>
-            </a:pPr>
-            <a:r>
-              <a:rPr sz="1300">
-                <a:solidFill>
-                  <a:srgbClr val="3D5466"/>
-                </a:solidFill>
-                <a:latin typeface="Arial"/>
-              </a:rPr>
-              <a:t>▸  Branchenrisiko (Kerngegenstand dieses Moduls)</a:t>
-            </a:r>
-          </a:p>
-          <a:p>
-            <a:pPr>
-              <a:spcBef>
-                <a:spcPts val="400"/>
-              </a:spcBef>
-              <a:spcAft>
-                <a:spcPts val="200"/>
-              </a:spcAft>
-            </a:pPr>
-            <a:r>
-              <a:rPr sz="1300">
-                <a:solidFill>
-                  <a:srgbClr val="3D5466"/>
-                </a:solidFill>
-                <a:latin typeface="Arial"/>
-              </a:rPr>
-              <a:t>▸  Marktposition und Wettbewerbsfähigkeit</a:t>
-            </a:r>
-          </a:p>
-          <a:p>
-            <a:pPr>
-              <a:spcBef>
-                <a:spcPts val="400"/>
-              </a:spcBef>
-              <a:spcAft>
-                <a:spcPts val="200"/>
-              </a:spcAft>
-            </a:pPr>
-            <a:r>
-              <a:rPr sz="1300">
-                <a:solidFill>
-                  <a:srgbClr val="3D5466"/>
-                </a:solidFill>
-                <a:latin typeface="Arial"/>
-              </a:rPr>
-              <a:t>▸  Nachfolgeplanung (bei KMU kritisch)</a:t>
+              <a:t>Die folgende Handlungsempfehlung-Karte verdichtet die Branchenrisikoprofile aus diesem Abschnitt zu konkreten Wenn-Dann-Impulsen für Kreditentscheidung und Kundengespräch.</a:t>
             </a:r>
           </a:p>
         </p:txBody>
@@ -8328,7 +9388,7 @@
             <a:avLst/>
           </a:prstGeom>
           <a:solidFill>
-            <a:srgbClr val="EDEDF3"/>
+            <a:srgbClr val="FFFFFF"/>
           </a:solidFill>
           <a:ln>
             <a:noFill/>
@@ -8429,51 +9489,43 @@
                 </a:solidFill>
                 <a:latin typeface="JetBrains Mono"/>
               </a:rPr>
-              <a:t>M05  ·  INHALT</a:t>
-            </a:r>
-          </a:p>
-        </p:txBody>
-      </p:sp>
-      <p:sp>
-        <p:nvSpPr>
-          <p:cNvPr id="5" name="Rectangle 4"/>
-          <p:cNvSpPr/>
-          <p:nvPr/>
-        </p:nvSpPr>
-        <p:spPr>
-          <a:xfrm>
-            <a:off x="0" y="1234440"/>
-            <a:ext cx="12188952" cy="12700"/>
-          </a:xfrm>
-          <a:prstGeom prst="rect">
-            <a:avLst/>
-          </a:prstGeom>
-          <a:solidFill>
-            <a:srgbClr val="D8DFE4"/>
-          </a:solidFill>
-          <a:ln>
-            <a:noFill/>
-          </a:ln>
-        </p:spPr>
-        <p:style>
-          <a:lnRef idx="1">
-            <a:schemeClr val="accent1"/>
-          </a:lnRef>
-          <a:fillRef idx="3">
-            <a:schemeClr val="accent1"/>
-          </a:fillRef>
-          <a:effectRef idx="2">
-            <a:schemeClr val="accent1"/>
-          </a:effectRef>
-          <a:fontRef idx="minor">
-            <a:schemeClr val="lt1"/>
-          </a:fontRef>
-        </p:style>
-        <p:txBody>
-          <a:bodyPr rtlCol="0" anchor="ctr"/>
-          <a:lstStyle/>
-          <a:p>
-            <a:pPr algn="ctr"/>
+              <a:t>M05  ·  SCHAUBILD</a:t>
+            </a:r>
+          </a:p>
+        </p:txBody>
+      </p:sp>
+      <p:sp>
+        <p:nvSpPr>
+          <p:cNvPr id="5" name="TextBox 4"/>
+          <p:cNvSpPr txBox="1"/>
+          <p:nvPr/>
+        </p:nvSpPr>
+        <p:spPr>
+          <a:xfrm>
+            <a:off x="685800" y="502920"/>
+            <a:ext cx="10817352" cy="594360"/>
+          </a:xfrm>
+          <a:prstGeom prst="rect">
+            <a:avLst/>
+          </a:prstGeom>
+          <a:noFill/>
+        </p:spPr>
+        <p:txBody>
+          <a:bodyPr wrap="square">
+            <a:spAutoFit/>
+          </a:bodyPr>
+          <a:lstStyle/>
+          <a:p>
+            <a:pPr algn="l"/>
+            <a:r>
+              <a:rPr sz="2000" b="1" i="0">
+                <a:solidFill>
+                  <a:srgbClr val="1F2C56"/>
+                </a:solidFill>
+                <a:latin typeface="Source Serif 4"/>
+              </a:rPr>
+              <a:t>Handlungsempfehlung</a:t>
+            </a:r>
           </a:p>
         </p:txBody>
       </p:sp>
@@ -8485,8 +9537,8 @@
         </p:nvSpPr>
         <p:spPr>
           <a:xfrm>
-            <a:off x="685800" y="502920"/>
-            <a:ext cx="36576" cy="658368"/>
+            <a:off x="685800" y="1143000"/>
+            <a:ext cx="10817352" cy="25400"/>
           </a:xfrm>
           <a:prstGeom prst="rect">
             <a:avLst/>
@@ -8520,295 +9572,33 @@
           </a:p>
         </p:txBody>
       </p:sp>
-      <p:sp>
-        <p:nvSpPr>
-          <p:cNvPr id="7" name="TextBox 6"/>
-          <p:cNvSpPr txBox="1"/>
-          <p:nvPr/>
-        </p:nvSpPr>
-        <p:spPr>
-          <a:xfrm>
-            <a:off x="813816" y="502920"/>
-            <a:ext cx="10634472" cy="685800"/>
-          </a:xfrm>
-          <a:prstGeom prst="rect">
-            <a:avLst/>
-          </a:prstGeom>
-          <a:noFill/>
-        </p:spPr>
-        <p:txBody>
-          <a:bodyPr wrap="square">
-            <a:spAutoFit/>
-          </a:bodyPr>
-          <a:lstStyle/>
-          <a:p>
-            <a:pPr algn="l"/>
-            <a:r>
-              <a:rPr sz="2400" b="1" i="0">
-                <a:solidFill>
-                  <a:srgbClr val="1F2C56"/>
-                </a:solidFill>
-                <a:latin typeface="Source Serif 4"/>
-              </a:rPr>
-              <a:t>Praxiscase: Bäckerei &amp; Konditorei Hofmann GmbH (Stuttgart, fiktiv)</a:t>
-            </a:r>
-          </a:p>
-        </p:txBody>
-      </p:sp>
-      <p:sp>
-        <p:nvSpPr>
-          <p:cNvPr id="8" name="TextBox 7"/>
-          <p:cNvSpPr txBox="1"/>
-          <p:nvPr/>
-        </p:nvSpPr>
-        <p:spPr>
-          <a:xfrm>
-            <a:off x="685800" y="1417320"/>
-            <a:ext cx="10817352" cy="5029200"/>
-          </a:xfrm>
-          <a:prstGeom prst="rect">
-            <a:avLst/>
-          </a:prstGeom>
-          <a:noFill/>
-        </p:spPr>
-        <p:txBody>
-          <a:bodyPr wrap="square">
-            <a:spAutoFit/>
-          </a:bodyPr>
-          <a:lstStyle/>
-          <a:p>
-            <a:pPr>
-              <a:spcBef>
-                <a:spcPts val="1000"/>
-              </a:spcBef>
-              <a:spcAft>
-                <a:spcPts val="200"/>
-              </a:spcAft>
-            </a:pPr>
-            <a:r>
-              <a:rPr sz="800" b="1">
-                <a:solidFill>
-                  <a:srgbClr val="78808C"/>
-                </a:solidFill>
-                <a:latin typeface="JetBrains Mono"/>
-              </a:rPr>
-              <a:t>4.4.1 UNTERNEHMENSPROFIL</a:t>
-            </a:r>
-          </a:p>
-          <a:p>
-            <a:pPr>
-              <a:spcBef>
-                <a:spcPts val="1000"/>
-              </a:spcBef>
-              <a:spcAft>
-                <a:spcPts val="200"/>
-              </a:spcAft>
-            </a:pPr>
-            <a:r>
-              <a:rPr sz="800" b="1">
-                <a:solidFill>
-                  <a:srgbClr val="78808C"/>
-                </a:solidFill>
-                <a:latin typeface="JetBrains Mono"/>
-              </a:rPr>
-              <a:t>4.4.2 FINANZIELLE SITUATION (JAHRESABSCHLUSS 2024, AUSZÜGE)</a:t>
-            </a:r>
-          </a:p>
-          <a:p>
-            <a:pPr>
-              <a:spcBef>
-                <a:spcPts val="400"/>
-              </a:spcBef>
-              <a:spcAft>
-                <a:spcPts val="200"/>
-              </a:spcAft>
-            </a:pPr>
-            <a:r>
-              <a:rPr sz="1200">
-                <a:solidFill>
-                  <a:srgbClr val="3D5466"/>
-                </a:solidFill>
-                <a:latin typeface="Arial"/>
-              </a:rPr>
-              <a:t>Bilanzauszug:</a:t>
-            </a:r>
-          </a:p>
-          <a:p>
-            <a:pPr>
-              <a:spcBef>
-                <a:spcPts val="400"/>
-              </a:spcBef>
-              <a:spcAft>
-                <a:spcPts val="200"/>
-              </a:spcAft>
-            </a:pPr>
-            <a:r>
-              <a:rPr sz="1200">
-                <a:solidFill>
-                  <a:srgbClr val="3D5466"/>
-                </a:solidFill>
-                <a:latin typeface="Arial"/>
-              </a:rPr>
-              <a:t>Gewinn- und Verlustrechnung 2024:</a:t>
-            </a:r>
-          </a:p>
-          <a:p>
-            <a:pPr>
-              <a:spcBef>
-                <a:spcPts val="400"/>
-              </a:spcBef>
-              <a:spcAft>
-                <a:spcPts val="200"/>
-              </a:spcAft>
-            </a:pPr>
-            <a:r>
-              <a:rPr sz="1200">
-                <a:solidFill>
-                  <a:srgbClr val="3D5466"/>
-                </a:solidFill>
-                <a:latin typeface="Arial"/>
-              </a:rPr>
-              <a:t>Kapitalflussrechnung 2024 (vereinfacht):</a:t>
-            </a:r>
-          </a:p>
-          <a:p>
-            <a:pPr>
-              <a:spcBef>
-                <a:spcPts val="1000"/>
-              </a:spcBef>
-              <a:spcAft>
-                <a:spcPts val="200"/>
-              </a:spcAft>
-            </a:pPr>
-            <a:r>
-              <a:rPr sz="800" b="1">
-                <a:solidFill>
-                  <a:srgbClr val="78808C"/>
-                </a:solidFill>
-                <a:latin typeface="JetBrains Mono"/>
-              </a:rPr>
-              <a:t>4.4.3 KREDITANFRAGE</a:t>
-            </a:r>
-          </a:p>
-          <a:p>
-            <a:pPr>
-              <a:spcBef>
-                <a:spcPts val="400"/>
-              </a:spcBef>
-              <a:spcAft>
-                <a:spcPts val="200"/>
-              </a:spcAft>
-            </a:pPr>
-            <a:r>
-              <a:rPr sz="1200">
-                <a:solidFill>
-                  <a:srgbClr val="3D5466"/>
-                </a:solidFill>
-                <a:latin typeface="Arial"/>
-              </a:rPr>
-              <a:t>Anlass: Investition in neue Backstube Kempten-Süd (170.000 €) + Filialmodernisierung Sonthofen (80.000 €)</a:t>
-            </a:r>
-          </a:p>
-          <a:p>
-            <a:pPr>
-              <a:spcBef>
-                <a:spcPts val="400"/>
-              </a:spcBef>
-              <a:spcAft>
-                <a:spcPts val="200"/>
-              </a:spcAft>
-            </a:pPr>
-            <a:r>
-              <a:rPr sz="1200">
-                <a:solidFill>
-                  <a:srgbClr val="3D5466"/>
-                </a:solidFill>
-                <a:latin typeface="Arial"/>
-              </a:rPr>
-              <a:t>Gesamtkreditbedarf: 250.000 € | Eigenanteil: 30.000 € | Kreditwunsch: 250.000 €</a:t>
-            </a:r>
-          </a:p>
-          <a:p>
-            <a:pPr>
-              <a:spcBef>
-                <a:spcPts val="1000"/>
-              </a:spcBef>
-              <a:spcAft>
-                <a:spcPts val="200"/>
-              </a:spcAft>
-            </a:pPr>
-            <a:r>
-              <a:rPr sz="800" b="1">
-                <a:solidFill>
-                  <a:srgbClr val="78808C"/>
-                </a:solidFill>
-                <a:latin typeface="JetBrains Mono"/>
-              </a:rPr>
-              <a:t>4.4.4 GESPRÄCHSVERLAUF: BRANCHENRISIKOANALYSE (BER = BERATER, GF = GESCHÄFTSFÜHRERIN)</a:t>
-            </a:r>
-          </a:p>
-          <a:p>
-            <a:pPr>
-              <a:spcBef>
-                <a:spcPts val="400"/>
-              </a:spcBef>
-              <a:spcAft>
-                <a:spcPts val="200"/>
-              </a:spcAft>
-            </a:pPr>
-            <a:r>
-              <a:rPr sz="1200">
-                <a:solidFill>
-                  <a:srgbClr val="3D5466"/>
-                </a:solidFill>
-                <a:latin typeface="Arial"/>
-              </a:rPr>
-              <a:t>Session 1 – Erstgespräch Branchenrisiko</a:t>
-            </a:r>
-          </a:p>
-          <a:p>
-            <a:pPr>
-              <a:spcBef>
-                <a:spcPts val="400"/>
-              </a:spcBef>
-              <a:spcAft>
-                <a:spcPts val="200"/>
-              </a:spcAft>
-            </a:pPr>
-            <a:r>
-              <a:rPr sz="1200">
-                <a:solidFill>
-                  <a:srgbClr val="3D5466"/>
-                </a:solidFill>
-                <a:latin typeface="Arial"/>
-              </a:rPr>
-              <a:t>GF: „Wir konnten die Preise nur um etwa 8–10 % erhöhen, ohne Kunden zu verlieren. Das hat die Marge deutlich gedrückt."</a:t>
-            </a:r>
-          </a:p>
-          <a:p>
-            <a:pPr>
-              <a:spcBef>
-                <a:spcPts val="400"/>
-              </a:spcBef>
-              <a:spcAft>
-                <a:spcPts val="200"/>
-              </a:spcAft>
-            </a:pPr>
-            <a:r>
-              <a:rPr sz="1200">
-                <a:solidFill>
-                  <a:srgbClr val="3D5466"/>
-                </a:solidFill>
-                <a:latin typeface="Arial"/>
-              </a:rPr>
-              <a:t>GF: „Nein, wir kaufen zu aktuellen Marktpreisen. Die Lieferanten bieten keine Festpreise an."</a:t>
-            </a:r>
-          </a:p>
-        </p:txBody>
-      </p:sp>
-      <p:sp>
-        <p:nvSpPr>
-          <p:cNvPr id="9" name="Rectangle 8"/>
+      <p:pic>
+        <p:nvPicPr>
+          <p:cNvPr id="7" name="Picture 6" descr="image.png"/>
+          <p:cNvPicPr>
+            <a:picLocks noChangeAspect="1"/>
+          </p:cNvPicPr>
+          <p:nvPr/>
+        </p:nvPicPr>
+        <p:blipFill>
+          <a:blip r:embed="rId2"/>
+          <a:stretch>
+            <a:fillRect/>
+          </a:stretch>
+        </p:blipFill>
+        <p:spPr>
+          <a:xfrm>
+            <a:off x="2303489" y="1325880"/>
+            <a:ext cx="7581973" cy="4937760"/>
+          </a:xfrm>
+          <a:prstGeom prst="rect">
+            <a:avLst/>
+          </a:prstGeom>
+        </p:spPr>
+      </p:pic>
+      <p:sp>
+        <p:nvSpPr>
+          <p:cNvPr id="8" name="Rectangle 7"/>
           <p:cNvSpPr/>
           <p:nvPr/>
         </p:nvSpPr>
@@ -8851,7 +9641,7 @@
       </p:sp>
       <p:sp>
         <p:nvSpPr>
-          <p:cNvPr id="10" name="TextBox 9"/>
+          <p:cNvPr id="9" name="TextBox 8"/>
           <p:cNvSpPr txBox="1"/>
           <p:nvPr/>
         </p:nvSpPr>
@@ -8880,6 +9670,41 @@
                 <a:latin typeface="JetBrains Mono"/>
               </a:rPr>
               <a:t>Benedikt Zoller Coaching  ·  FKB Campus  ·  M05</a:t>
+            </a:r>
+          </a:p>
+        </p:txBody>
+      </p:sp>
+      <p:sp>
+        <p:nvSpPr>
+          <p:cNvPr id="10" name="TextBox 9"/>
+          <p:cNvSpPr txBox="1"/>
+          <p:nvPr/>
+        </p:nvSpPr>
+        <p:spPr>
+          <a:xfrm>
+            <a:off x="7176211" y="6583680"/>
+            <a:ext cx="4326940" cy="256032"/>
+          </a:xfrm>
+          <a:prstGeom prst="rect">
+            <a:avLst/>
+          </a:prstGeom>
+          <a:noFill/>
+        </p:spPr>
+        <p:txBody>
+          <a:bodyPr wrap="none">
+            <a:spAutoFit/>
+          </a:bodyPr>
+          <a:lstStyle/>
+          <a:p>
+            <a:pPr algn="r"/>
+            <a:r>
+              <a:rPr sz="700">
+                <a:solidFill>
+                  <a:srgbClr val="A0B4D2"/>
+                </a:solidFill>
+                <a:latin typeface="JetBrains Mono"/>
+              </a:rPr>
+              <a:t>Schaubild</a:t>
             </a:r>
           </a:p>
         </p:txBody>

</xml_diff>

<commit_message>
Quell-MD-Hygiene A1: 7 Module neu gesynct (Material als AB-X, nur im PDF)
Co-Authored-By: Claude Opus 4.8 <noreply@anthropic.com>
</commit_message>
<xml_diff>
--- a/protected-downloads/praesentation/M05.pptx
+++ b/protected-downloads/praesentation/M05.pptx
@@ -8272,7 +8272,7 @@
                 </a:solidFill>
                 <a:latin typeface="Source Serif 4"/>
               </a:rPr>
-              <a:t>Arbeitsblatt: Branchenrisiko-Analyse-Template</a:t>
+              <a:t>AB-1: Branchenrisiko-Analyse-Template</a:t>
             </a:r>
           </a:p>
         </p:txBody>
@@ -8775,7 +8775,7 @@
                 </a:solidFill>
                 <a:latin typeface="Source Serif 4"/>
               </a:rPr>
-              <a:t>Arbeitsblatt: Branchenrisiko-Analyse-Template</a:t>
+              <a:t>AB-1: Branchenrisiko-Analyse-Template</a:t>
             </a:r>
           </a:p>
         </p:txBody>

</xml_diff>